<commit_message>
data-eng decks 5-4 (w5d4s0 신설 · s1~s4 실측 반영) + bundles
Co-Authored-By: Claude Opus 5.5 <noreply@anthropic.com>
</commit_message>
<xml_diff>
--- a/data-eng/decks/w5d4s1.pptx
+++ b/data-eng/decks/w5d4s1.pptx
@@ -3100,7 +3100,7 @@
       <p:grpSpPr/>
       <p:sp>
         <p:nvSpPr>
-          <p:cNvPr id="2" name="Oval 1"/>
+          <p:cNvPr id="2" name="deckgen:decor"/>
           <p:cNvSpPr/>
           <p:nvPr/>
         </p:nvSpPr>
@@ -3130,7 +3130,7 @@
       </p:sp>
       <p:sp>
         <p:nvSpPr>
-          <p:cNvPr id="3" name="Oval 2"/>
+          <p:cNvPr id="3" name="deckgen:decor"/>
           <p:cNvSpPr/>
           <p:nvPr/>
         </p:nvSpPr>
@@ -3160,7 +3160,7 @@
       </p:sp>
       <p:sp>
         <p:nvSpPr>
-          <p:cNvPr id="4" name="Oval 3"/>
+          <p:cNvPr id="4" name="deckgen:decor"/>
           <p:cNvSpPr/>
           <p:nvPr/>
         </p:nvSpPr>
@@ -3190,7 +3190,7 @@
       </p:sp>
       <p:sp>
         <p:nvSpPr>
-          <p:cNvPr id="5" name="Rectangle 4"/>
+          <p:cNvPr id="5" name="deckgen:decor"/>
           <p:cNvSpPr/>
           <p:nvPr/>
         </p:nvSpPr>
@@ -3220,7 +3220,7 @@
       </p:sp>
       <p:sp>
         <p:nvSpPr>
-          <p:cNvPr id="6" name="Oval 5"/>
+          <p:cNvPr id="6" name="deckgen:decor"/>
           <p:cNvSpPr/>
           <p:nvPr/>
         </p:nvSpPr>
@@ -3250,7 +3250,7 @@
       </p:sp>
       <p:sp>
         <p:nvSpPr>
-          <p:cNvPr id="7" name="Oval 6"/>
+          <p:cNvPr id="7" name="deckgen:decor"/>
           <p:cNvSpPr/>
           <p:nvPr/>
         </p:nvSpPr>
@@ -3280,7 +3280,7 @@
       </p:sp>
       <p:sp>
         <p:nvSpPr>
-          <p:cNvPr id="8" name="Oval 7"/>
+          <p:cNvPr id="8" name="deckgen:decor"/>
           <p:cNvSpPr/>
           <p:nvPr/>
         </p:nvSpPr>
@@ -3310,7 +3310,7 @@
       </p:sp>
       <p:sp>
         <p:nvSpPr>
-          <p:cNvPr id="9" name="Oval 8"/>
+          <p:cNvPr id="9" name="deckgen:decor"/>
           <p:cNvSpPr/>
           <p:nvPr/>
         </p:nvSpPr>
@@ -3340,7 +3340,7 @@
       </p:sp>
       <p:sp>
         <p:nvSpPr>
-          <p:cNvPr id="10" name="Rectangle 9"/>
+          <p:cNvPr id="10" name="deckgen:decor"/>
           <p:cNvSpPr/>
           <p:nvPr/>
         </p:nvSpPr>
@@ -3600,7 +3600,7 @@
       <p:grpSpPr/>
       <p:sp>
         <p:nvSpPr>
-          <p:cNvPr id="2" name="Oval 1"/>
+          <p:cNvPr id="2" name="deckgen:decor"/>
           <p:cNvSpPr/>
           <p:nvPr/>
         </p:nvSpPr>
@@ -3630,7 +3630,7 @@
       </p:sp>
       <p:sp>
         <p:nvSpPr>
-          <p:cNvPr id="3" name="Oval 2"/>
+          <p:cNvPr id="3" name="deckgen:decor"/>
           <p:cNvSpPr/>
           <p:nvPr/>
         </p:nvSpPr>
@@ -3660,7 +3660,7 @@
       </p:sp>
       <p:sp>
         <p:nvSpPr>
-          <p:cNvPr id="4" name="Oval 3"/>
+          <p:cNvPr id="4" name="deckgen:decor"/>
           <p:cNvSpPr/>
           <p:nvPr/>
         </p:nvSpPr>
@@ -3808,12 +3808,12 @@
         </p:nvSpPr>
         <p:spPr>
           <a:xfrm>
-            <a:off x="1143000" y="2990850"/>
-            <a:ext cx="16002000" cy="819150"/>
+            <a:off x="1143000" y="2867025"/>
+            <a:ext cx="16002000" cy="742950"/>
           </a:xfrm>
           <a:prstGeom prst="roundRect">
             <a:avLst>
-              <a:gd name="adj" fmla="val 5813"/>
+              <a:gd name="adj" fmla="val 6410"/>
             </a:avLst>
           </a:prstGeom>
           <a:solidFill>
@@ -3842,7 +3842,7 @@
         </p:nvSpPr>
         <p:spPr>
           <a:xfrm>
-            <a:off x="1390650" y="3133725"/>
+            <a:off x="1390650" y="2971800"/>
             <a:ext cx="533400" cy="533400"/>
           </a:xfrm>
           <a:prstGeom prst="ellipse">
@@ -3872,7 +3872,7 @@
         </p:nvSpPr>
         <p:spPr>
           <a:xfrm>
-            <a:off x="1390650" y="3257550"/>
+            <a:off x="1390650" y="3095625"/>
             <a:ext cx="533400" cy="323850"/>
           </a:xfrm>
           <a:prstGeom prst="rect">
@@ -3913,8 +3913,8 @@
         </p:nvSpPr>
         <p:spPr>
           <a:xfrm>
-            <a:off x="2190750" y="2990850"/>
-            <a:ext cx="14573250" cy="819150"/>
+            <a:off x="2190750" y="2867025"/>
+            <a:ext cx="14573250" cy="742950"/>
           </a:xfrm>
           <a:prstGeom prst="rect">
             <a:avLst/>
@@ -3933,7 +3933,7 @@
               </a:lnSpc>
             </a:pPr>
             <a:r>
-              <a:rPr sz="2325" b="1">
+              <a:rPr sz="2100" b="1">
                 <a:solidFill>
                   <a:srgbClr val="0D2B5E"/>
                 </a:solidFill>
@@ -3954,12 +3954,12 @@
         </p:nvSpPr>
         <p:spPr>
           <a:xfrm>
-            <a:off x="1143000" y="3981450"/>
-            <a:ext cx="16002000" cy="819150"/>
+            <a:off x="1143000" y="3724275"/>
+            <a:ext cx="16002000" cy="742950"/>
           </a:xfrm>
           <a:prstGeom prst="roundRect">
             <a:avLst>
-              <a:gd name="adj" fmla="val 5813"/>
+              <a:gd name="adj" fmla="val 6410"/>
             </a:avLst>
           </a:prstGeom>
           <a:solidFill>
@@ -3988,7 +3988,7 @@
         </p:nvSpPr>
         <p:spPr>
           <a:xfrm>
-            <a:off x="1390650" y="4124325"/>
+            <a:off x="1390650" y="3829050"/>
             <a:ext cx="533400" cy="533400"/>
           </a:xfrm>
           <a:prstGeom prst="ellipse">
@@ -4018,7 +4018,7 @@
         </p:nvSpPr>
         <p:spPr>
           <a:xfrm>
-            <a:off x="1390650" y="4248150"/>
+            <a:off x="1390650" y="3952875"/>
             <a:ext cx="533400" cy="323850"/>
           </a:xfrm>
           <a:prstGeom prst="rect">
@@ -4059,8 +4059,8 @@
         </p:nvSpPr>
         <p:spPr>
           <a:xfrm>
-            <a:off x="2190750" y="3981450"/>
-            <a:ext cx="14573250" cy="819150"/>
+            <a:off x="2190750" y="3724275"/>
+            <a:ext cx="14573250" cy="742950"/>
           </a:xfrm>
           <a:prstGeom prst="rect">
             <a:avLst/>
@@ -4079,7 +4079,7 @@
               </a:lnSpc>
             </a:pPr>
             <a:r>
-              <a:rPr sz="2325" b="1">
+              <a:rPr sz="2100" b="1">
                 <a:solidFill>
                   <a:srgbClr val="0D2B5E"/>
                 </a:solidFill>
@@ -4100,12 +4100,12 @@
         </p:nvSpPr>
         <p:spPr>
           <a:xfrm>
-            <a:off x="1143000" y="4972050"/>
-            <a:ext cx="16002000" cy="819150"/>
+            <a:off x="1143000" y="4581525"/>
+            <a:ext cx="16002000" cy="742950"/>
           </a:xfrm>
           <a:prstGeom prst="roundRect">
             <a:avLst>
-              <a:gd name="adj" fmla="val 5813"/>
+              <a:gd name="adj" fmla="val 6410"/>
             </a:avLst>
           </a:prstGeom>
           <a:solidFill>
@@ -4134,7 +4134,7 @@
         </p:nvSpPr>
         <p:spPr>
           <a:xfrm>
-            <a:off x="1390650" y="5114925"/>
+            <a:off x="1390650" y="4686300"/>
             <a:ext cx="533400" cy="533400"/>
           </a:xfrm>
           <a:prstGeom prst="ellipse">
@@ -4164,7 +4164,7 @@
         </p:nvSpPr>
         <p:spPr>
           <a:xfrm>
-            <a:off x="1390650" y="5238750"/>
+            <a:off x="1390650" y="4810125"/>
             <a:ext cx="533400" cy="323850"/>
           </a:xfrm>
           <a:prstGeom prst="rect">
@@ -4205,8 +4205,8 @@
         </p:nvSpPr>
         <p:spPr>
           <a:xfrm>
-            <a:off x="2190750" y="4972050"/>
-            <a:ext cx="14573250" cy="819150"/>
+            <a:off x="2190750" y="4581525"/>
+            <a:ext cx="14573250" cy="742950"/>
           </a:xfrm>
           <a:prstGeom prst="rect">
             <a:avLst/>
@@ -4225,7 +4225,7 @@
               </a:lnSpc>
             </a:pPr>
             <a:r>
-              <a:rPr sz="2325" b="1">
+              <a:rPr sz="2100" b="1">
                 <a:solidFill>
                   <a:srgbClr val="0D2B5E"/>
                 </a:solidFill>
@@ -4246,12 +4246,12 @@
         </p:nvSpPr>
         <p:spPr>
           <a:xfrm>
-            <a:off x="1143000" y="5962650"/>
-            <a:ext cx="16002000" cy="819150"/>
+            <a:off x="1143000" y="5438775"/>
+            <a:ext cx="16002000" cy="742950"/>
           </a:xfrm>
           <a:prstGeom prst="roundRect">
             <a:avLst>
-              <a:gd name="adj" fmla="val 5813"/>
+              <a:gd name="adj" fmla="val 6410"/>
             </a:avLst>
           </a:prstGeom>
           <a:solidFill>
@@ -4280,7 +4280,7 @@
         </p:nvSpPr>
         <p:spPr>
           <a:xfrm>
-            <a:off x="1390650" y="6105525"/>
+            <a:off x="1390650" y="5543550"/>
             <a:ext cx="533400" cy="533400"/>
           </a:xfrm>
           <a:prstGeom prst="ellipse">
@@ -4310,7 +4310,7 @@
         </p:nvSpPr>
         <p:spPr>
           <a:xfrm>
-            <a:off x="1390650" y="6229350"/>
+            <a:off x="1390650" y="5667375"/>
             <a:ext cx="533400" cy="323850"/>
           </a:xfrm>
           <a:prstGeom prst="rect">
@@ -4351,8 +4351,8 @@
         </p:nvSpPr>
         <p:spPr>
           <a:xfrm>
-            <a:off x="2190750" y="5962650"/>
-            <a:ext cx="14573250" cy="819150"/>
+            <a:off x="2190750" y="5438775"/>
+            <a:ext cx="14573250" cy="742950"/>
           </a:xfrm>
           <a:prstGeom prst="rect">
             <a:avLst/>
@@ -4371,7 +4371,7 @@
               </a:lnSpc>
             </a:pPr>
             <a:r>
-              <a:rPr sz="2325" b="1">
+              <a:rPr sz="2100" b="1">
                 <a:solidFill>
                   <a:srgbClr val="0D2B5E"/>
                 </a:solidFill>
@@ -4392,12 +4392,12 @@
         </p:nvSpPr>
         <p:spPr>
           <a:xfrm>
-            <a:off x="1143000" y="6953250"/>
-            <a:ext cx="16002000" cy="819150"/>
+            <a:off x="1143000" y="6296025"/>
+            <a:ext cx="16002000" cy="742950"/>
           </a:xfrm>
           <a:prstGeom prst="roundRect">
             <a:avLst>
-              <a:gd name="adj" fmla="val 5813"/>
+              <a:gd name="adj" fmla="val 6410"/>
             </a:avLst>
           </a:prstGeom>
           <a:solidFill>
@@ -4426,7 +4426,7 @@
         </p:nvSpPr>
         <p:spPr>
           <a:xfrm>
-            <a:off x="1390650" y="7096125"/>
+            <a:off x="1390650" y="6400800"/>
             <a:ext cx="533400" cy="533400"/>
           </a:xfrm>
           <a:prstGeom prst="ellipse">
@@ -4456,7 +4456,7 @@
         </p:nvSpPr>
         <p:spPr>
           <a:xfrm>
-            <a:off x="1390650" y="7219950"/>
+            <a:off x="1390650" y="6524625"/>
             <a:ext cx="533400" cy="323850"/>
           </a:xfrm>
           <a:prstGeom prst="rect">
@@ -4497,8 +4497,8 @@
         </p:nvSpPr>
         <p:spPr>
           <a:xfrm>
-            <a:off x="2190750" y="6953250"/>
-            <a:ext cx="14573250" cy="819150"/>
+            <a:off x="2190750" y="6296025"/>
+            <a:ext cx="14573250" cy="742950"/>
           </a:xfrm>
           <a:prstGeom prst="rect">
             <a:avLst/>
@@ -4517,7 +4517,7 @@
               </a:lnSpc>
             </a:pPr>
             <a:r>
-              <a:rPr sz="2325" b="1">
+              <a:rPr sz="2100" b="1">
                 <a:solidFill>
                   <a:srgbClr val="0D2B5E"/>
                 </a:solidFill>
@@ -4532,7 +4532,153 @@
       </p:sp>
       <p:sp>
         <p:nvSpPr>
-          <p:cNvPr id="28" name="Rectangle 27"/>
+          <p:cNvPr id="28" name="Rounded Rectangle 27"/>
+          <p:cNvSpPr/>
+          <p:nvPr/>
+        </p:nvSpPr>
+        <p:spPr>
+          <a:xfrm>
+            <a:off x="1143000" y="7153275"/>
+            <a:ext cx="16002000" cy="742950"/>
+          </a:xfrm>
+          <a:prstGeom prst="roundRect">
+            <a:avLst>
+              <a:gd name="adj" fmla="val 6410"/>
+            </a:avLst>
+          </a:prstGeom>
+          <a:solidFill>
+            <a:srgbClr val="FAFBFD"/>
+          </a:solidFill>
+          <a:ln w="9525">
+            <a:solidFill>
+              <a:srgbClr val="DCE1E8"/>
+            </a:solidFill>
+          </a:ln>
+          <a:effectLst/>
+        </p:spPr>
+        <p:txBody>
+          <a:bodyPr rtlCol="0" anchor="ctr" wrap="square"/>
+          <a:lstStyle/>
+          <a:p>
+            <a:pPr algn="ctr"/>
+          </a:p>
+        </p:txBody>
+      </p:sp>
+      <p:sp>
+        <p:nvSpPr>
+          <p:cNvPr id="29" name="Oval 28"/>
+          <p:cNvSpPr/>
+          <p:nvPr/>
+        </p:nvSpPr>
+        <p:spPr>
+          <a:xfrm>
+            <a:off x="1390650" y="7258050"/>
+            <a:ext cx="533400" cy="533400"/>
+          </a:xfrm>
+          <a:prstGeom prst="ellipse">
+            <a:avLst/>
+          </a:prstGeom>
+          <a:solidFill>
+            <a:srgbClr val="0D2B5E"/>
+          </a:solidFill>
+          <a:ln>
+            <a:noFill/>
+          </a:ln>
+          <a:effectLst/>
+        </p:spPr>
+        <p:txBody>
+          <a:bodyPr rtlCol="0" anchor="ctr" wrap="square"/>
+          <a:lstStyle/>
+          <a:p>
+            <a:pPr algn="ctr"/>
+          </a:p>
+        </p:txBody>
+      </p:sp>
+      <p:sp>
+        <p:nvSpPr>
+          <p:cNvPr id="30" name="TextBox 29"/>
+          <p:cNvSpPr txBox="1"/>
+          <p:nvPr/>
+        </p:nvSpPr>
+        <p:spPr>
+          <a:xfrm>
+            <a:off x="1390650" y="7381875"/>
+            <a:ext cx="533400" cy="323850"/>
+          </a:xfrm>
+          <a:prstGeom prst="rect">
+            <a:avLst/>
+          </a:prstGeom>
+          <a:noFill/>
+        </p:spPr>
+        <p:txBody>
+          <a:bodyPr wrap="square" lIns="0" rIns="0" tIns="0" bIns="0" anchor="t">
+            <a:spAutoFit/>
+          </a:bodyPr>
+          <a:lstStyle/>
+          <a:p>
+            <a:pPr algn="ctr">
+              <a:lnSpc>
+                <a:spcPct val="100000"/>
+              </a:lnSpc>
+            </a:pPr>
+            <a:r>
+              <a:rPr sz="2100" b="1">
+                <a:solidFill>
+                  <a:srgbClr val="FFFFFF"/>
+                </a:solidFill>
+                <a:latin typeface="Pretendard"/>
+                <a:ea typeface="Pretendard"/>
+                <a:cs typeface="Pretendard"/>
+              </a:rPr>
+              <a:t>6</a:t>
+            </a:r>
+          </a:p>
+        </p:txBody>
+      </p:sp>
+      <p:sp>
+        <p:nvSpPr>
+          <p:cNvPr id="31" name="TextBox 30"/>
+          <p:cNvSpPr txBox="1"/>
+          <p:nvPr/>
+        </p:nvSpPr>
+        <p:spPr>
+          <a:xfrm>
+            <a:off x="2190750" y="7153275"/>
+            <a:ext cx="14573250" cy="742950"/>
+          </a:xfrm>
+          <a:prstGeom prst="rect">
+            <a:avLst/>
+          </a:prstGeom>
+          <a:noFill/>
+        </p:spPr>
+        <p:txBody>
+          <a:bodyPr wrap="square" lIns="0" rIns="0" tIns="0" bIns="0" anchor="ctr">
+            <a:spAutoFit/>
+          </a:bodyPr>
+          <a:lstStyle/>
+          <a:p>
+            <a:pPr algn="l">
+              <a:lnSpc>
+                <a:spcPct val="100000"/>
+              </a:lnSpc>
+            </a:pPr>
+            <a:r>
+              <a:rPr sz="2100" b="1">
+                <a:solidFill>
+                  <a:srgbClr val="0D2B5E"/>
+                </a:solidFill>
+                <a:latin typeface="Pretendard"/>
+                <a:ea typeface="Pretendard"/>
+                <a:cs typeface="Pretendard"/>
+              </a:rPr>
+              <a:t>조인 방식은 추정 크기로 정해진다 — 모르면 F.broadcast 로 알려 준다</a:t>
+            </a:r>
+          </a:p>
+        </p:txBody>
+      </p:sp>
+      <p:sp>
+        <p:nvSpPr>
+          <p:cNvPr id="32" name="Rectangle 31"/>
           <p:cNvSpPr/>
           <p:nvPr/>
         </p:nvSpPr>
@@ -4562,7 +4708,7 @@
       </p:sp>
       <p:sp>
         <p:nvSpPr>
-          <p:cNvPr id="29" name="TextBox 28"/>
+          <p:cNvPr id="33" name="TextBox 32"/>
           <p:cNvSpPr txBox="1"/>
           <p:nvPr/>
         </p:nvSpPr>
@@ -4603,7 +4749,7 @@
       </p:sp>
       <p:sp>
         <p:nvSpPr>
-          <p:cNvPr id="30" name="TextBox 29"/>
+          <p:cNvPr id="34" name="TextBox 33"/>
           <p:cNvSpPr txBox="1"/>
           <p:nvPr/>
         </p:nvSpPr>
@@ -4662,7 +4808,7 @@
       <p:grpSpPr/>
       <p:sp>
         <p:nvSpPr>
-          <p:cNvPr id="2" name="Oval 1"/>
+          <p:cNvPr id="2" name="deckgen:decor"/>
           <p:cNvSpPr/>
           <p:nvPr/>
         </p:nvSpPr>
@@ -4692,7 +4838,7 @@
       </p:sp>
       <p:sp>
         <p:nvSpPr>
-          <p:cNvPr id="3" name="Oval 2"/>
+          <p:cNvPr id="3" name="deckgen:decor"/>
           <p:cNvSpPr/>
           <p:nvPr/>
         </p:nvSpPr>
@@ -5332,7 +5478,7 @@
                 <a:ea typeface="Pretendard"/>
                 <a:cs typeface="Pretendard"/>
               </a:rPr>
-              <a:t>explain() 에서 BroadcastHashJoin 찾기</a:t>
+              <a:t>explain() — SortMergeJoin 과 F.broadcast</a:t>
             </a:r>
           </a:p>
         </p:txBody>
@@ -5444,7 +5590,7 @@
                 <a:ea typeface="Pretendard"/>
                 <a:cs typeface="Pretendard"/>
               </a:rPr>
-              <a:t>5-3 compose 기동 · PySpark 셸 옵션</a:t>
+              <a:t>실습점검으로 클러스터 켜기 · bash lake-pyspark.sh</a:t>
             </a:r>
           </a:p>
         </p:txBody>
@@ -5469,7 +5615,7 @@
       <p:grpSpPr/>
       <p:sp>
         <p:nvSpPr>
-          <p:cNvPr id="2" name="Oval 1"/>
+          <p:cNvPr id="2" name="deckgen:decor"/>
           <p:cNvSpPr/>
           <p:nvPr/>
         </p:nvSpPr>
@@ -5499,7 +5645,7 @@
       </p:sp>
       <p:sp>
         <p:nvSpPr>
-          <p:cNvPr id="3" name="Oval 2"/>
+          <p:cNvPr id="3" name="deckgen:decor"/>
           <p:cNvSpPr/>
           <p:nvPr/>
         </p:nvSpPr>
@@ -5529,7 +5675,7 @@
       </p:sp>
       <p:sp>
         <p:nvSpPr>
-          <p:cNvPr id="4" name="Oval 3"/>
+          <p:cNvPr id="4" name="deckgen:decor"/>
           <p:cNvSpPr/>
           <p:nvPr/>
         </p:nvSpPr>
@@ -6248,7 +6394,7 @@
                 <a:ea typeface="Pretendard"/>
                 <a:cs typeface="Pretendard"/>
               </a:rPr>
-              <a:t>조인 how 다섯 가지와 Broadcast·Sort Merge 두 방식을 구별한다</a:t>
+              <a:t>조인 how 다섯 가지와 두 조인 방식이 정해지는 기준을 안다</a:t>
             </a:r>
           </a:p>
         </p:txBody>
@@ -6460,7 +6606,7 @@
       <p:grpSpPr/>
       <p:sp>
         <p:nvSpPr>
-          <p:cNvPr id="2" name="Oval 1"/>
+          <p:cNvPr id="2" name="deckgen:decor"/>
           <p:cNvSpPr/>
           <p:nvPr/>
         </p:nvSpPr>
@@ -6490,7 +6636,7 @@
       </p:sp>
       <p:sp>
         <p:nvSpPr>
-          <p:cNvPr id="3" name="Oval 2"/>
+          <p:cNvPr id="3" name="deckgen:decor"/>
           <p:cNvSpPr/>
           <p:nvPr/>
         </p:nvSpPr>
@@ -6520,7 +6666,7 @@
       </p:sp>
       <p:sp>
         <p:nvSpPr>
-          <p:cNvPr id="4" name="Oval 3"/>
+          <p:cNvPr id="4" name="deckgen:decor"/>
           <p:cNvSpPr/>
           <p:nvPr/>
         </p:nvSpPr>
@@ -8662,7 +8808,7 @@
       <p:grpSpPr/>
       <p:sp>
         <p:nvSpPr>
-          <p:cNvPr id="2" name="Oval 1"/>
+          <p:cNvPr id="2" name="deckgen:decor"/>
           <p:cNvSpPr/>
           <p:nvPr/>
         </p:nvSpPr>
@@ -8692,7 +8838,7 @@
       </p:sp>
       <p:sp>
         <p:nvSpPr>
-          <p:cNvPr id="3" name="Oval 2"/>
+          <p:cNvPr id="3" name="deckgen:decor"/>
           <p:cNvSpPr/>
           <p:nvPr/>
         </p:nvSpPr>
@@ -8722,7 +8868,7 @@
       </p:sp>
       <p:sp>
         <p:nvSpPr>
-          <p:cNvPr id="4" name="Oval 3"/>
+          <p:cNvPr id="4" name="deckgen:decor"/>
           <p:cNvSpPr/>
           <p:nvPr/>
         </p:nvSpPr>
@@ -10050,7 +10196,7 @@
       <p:grpSpPr/>
       <p:sp>
         <p:nvSpPr>
-          <p:cNvPr id="2" name="Oval 1"/>
+          <p:cNvPr id="2" name="deckgen:decor"/>
           <p:cNvSpPr/>
           <p:nvPr/>
         </p:nvSpPr>
@@ -10080,7 +10226,7 @@
       </p:sp>
       <p:sp>
         <p:nvSpPr>
-          <p:cNvPr id="3" name="Oval 2"/>
+          <p:cNvPr id="3" name="deckgen:decor"/>
           <p:cNvSpPr/>
           <p:nvPr/>
         </p:nvSpPr>
@@ -10110,7 +10256,7 @@
       </p:sp>
       <p:sp>
         <p:nvSpPr>
-          <p:cNvPr id="4" name="Oval 3"/>
+          <p:cNvPr id="4" name="deckgen:decor"/>
           <p:cNvSpPr/>
           <p:nvPr/>
         </p:nvSpPr>
@@ -11111,7 +11257,7 @@
       <p:grpSpPr/>
       <p:sp>
         <p:nvSpPr>
-          <p:cNvPr id="2" name="Oval 1"/>
+          <p:cNvPr id="2" name="deckgen:decor"/>
           <p:cNvSpPr/>
           <p:nvPr/>
         </p:nvSpPr>
@@ -11141,7 +11287,7 @@
       </p:sp>
       <p:sp>
         <p:nvSpPr>
-          <p:cNvPr id="3" name="Oval 2"/>
+          <p:cNvPr id="3" name="deckgen:decor"/>
           <p:cNvSpPr/>
           <p:nvPr/>
         </p:nvSpPr>
@@ -11171,7 +11317,7 @@
       </p:sp>
       <p:sp>
         <p:nvSpPr>
-          <p:cNvPr id="4" name="Oval 3"/>
+          <p:cNvPr id="4" name="deckgen:decor"/>
           <p:cNvSpPr/>
           <p:nvPr/>
         </p:nvSpPr>
@@ -12191,7 +12337,7 @@
       <p:grpSpPr/>
       <p:sp>
         <p:nvSpPr>
-          <p:cNvPr id="2" name="Oval 1"/>
+          <p:cNvPr id="2" name="deckgen:decor"/>
           <p:cNvSpPr/>
           <p:nvPr/>
         </p:nvSpPr>
@@ -12221,7 +12367,7 @@
       </p:sp>
       <p:sp>
         <p:nvSpPr>
-          <p:cNvPr id="3" name="Oval 2"/>
+          <p:cNvPr id="3" name="deckgen:decor"/>
           <p:cNvSpPr/>
           <p:nvPr/>
         </p:nvSpPr>
@@ -12251,7 +12397,7 @@
       </p:sp>
       <p:sp>
         <p:nvSpPr>
-          <p:cNvPr id="4" name="Oval 3"/>
+          <p:cNvPr id="4" name="deckgen:decor"/>
           <p:cNvSpPr/>
           <p:nvPr/>
         </p:nvSpPr>
@@ -13902,7 +14048,7 @@
       <p:grpSpPr/>
       <p:sp>
         <p:nvSpPr>
-          <p:cNvPr id="2" name="Oval 1"/>
+          <p:cNvPr id="2" name="deckgen:decor"/>
           <p:cNvSpPr/>
           <p:nvPr/>
         </p:nvSpPr>
@@ -13932,7 +14078,7 @@
       </p:sp>
       <p:sp>
         <p:nvSpPr>
-          <p:cNvPr id="3" name="Oval 2"/>
+          <p:cNvPr id="3" name="deckgen:decor"/>
           <p:cNvSpPr/>
           <p:nvPr/>
         </p:nvSpPr>
@@ -13962,7 +14108,7 @@
       </p:sp>
       <p:sp>
         <p:nvSpPr>
-          <p:cNvPr id="4" name="Oval 3"/>
+          <p:cNvPr id="4" name="deckgen:decor"/>
           <p:cNvSpPr/>
           <p:nvPr/>
         </p:nvSpPr>
@@ -14963,7 +15109,7 @@
       <p:grpSpPr/>
       <p:sp>
         <p:nvSpPr>
-          <p:cNvPr id="2" name="Oval 1"/>
+          <p:cNvPr id="2" name="deckgen:decor"/>
           <p:cNvSpPr/>
           <p:nvPr/>
         </p:nvSpPr>
@@ -14993,7 +15139,7 @@
       </p:sp>
       <p:sp>
         <p:nvSpPr>
-          <p:cNvPr id="3" name="Oval 2"/>
+          <p:cNvPr id="3" name="deckgen:decor"/>
           <p:cNvSpPr/>
           <p:nvPr/>
         </p:nvSpPr>
@@ -15023,7 +15169,7 @@
       </p:sp>
       <p:sp>
         <p:nvSpPr>
-          <p:cNvPr id="4" name="Oval 3"/>
+          <p:cNvPr id="4" name="deckgen:decor"/>
           <p:cNvSpPr/>
           <p:nvPr/>
         </p:nvSpPr>
@@ -15128,7 +15274,7 @@
                 <a:ea typeface="Pretendard"/>
                 <a:cs typeface="Pretendard"/>
               </a:rPr>
-              <a:t>Spark 조인의 두 가지 방식 — explain() 에서 찾을 이름</a:t>
+              <a:t>조인 방식은 Spark 가 추정한 크기로 정한다</a:t>
             </a:r>
           </a:p>
         </p:txBody>
@@ -15240,7 +15386,7 @@
                 <a:ea typeface="Pretendard"/>
                 <a:cs typeface="Pretendard"/>
               </a:rPr>
-              <a:t>한쪽이 작을 때(기본 10MB 이하)</a:t>
+              <a:t>한쪽이 작다고 Spark 가 알 때(기본 10MB 이하)</a:t>
             </a:r>
           </a:p>
         </p:txBody>
@@ -15281,20 +15427,20 @@
       </p:sp>
       <p:sp>
         <p:nvSpPr>
-          <p:cNvPr id="11" name="Rectangle 10"/>
-          <p:cNvSpPr/>
-          <p:nvPr/>
-        </p:nvSpPr>
-        <p:spPr>
-          <a:xfrm>
-            <a:off x="1390650" y="4838700"/>
-            <a:ext cx="3333274" cy="599122"/>
-          </a:xfrm>
-          <a:prstGeom prst="rect">
-            <a:avLst/>
-          </a:prstGeom>
-          <a:solidFill>
-            <a:srgbClr val="0D2B5E"/>
+          <p:cNvPr id="11" name="Oval 10"/>
+          <p:cNvSpPr/>
+          <p:nvPr/>
+        </p:nvSpPr>
+        <p:spPr>
+          <a:xfrm>
+            <a:off x="1447800" y="5016817"/>
+            <a:ext cx="97155" cy="97155"/>
+          </a:xfrm>
+          <a:prstGeom prst="ellipse">
+            <a:avLst/>
+          </a:prstGeom>
+          <a:solidFill>
+            <a:srgbClr val="1E5BC6"/>
           </a:solidFill>
           <a:ln>
             <a:noFill/>
@@ -15317,8 +15463,8 @@
         </p:nvSpPr>
         <p:spPr>
           <a:xfrm>
-            <a:off x="1390650" y="4838700"/>
-            <a:ext cx="3333274" cy="599122"/>
+            <a:off x="1633538" y="4838700"/>
+            <a:ext cx="6634162" cy="453390"/>
           </a:xfrm>
           <a:prstGeom prst="rect">
             <a:avLst/>
@@ -15331,39 +15477,263 @@
           </a:bodyPr>
           <a:lstStyle/>
           <a:p>
-            <a:pPr algn="ctr">
-              <a:lnSpc>
-                <a:spcPct val="100000"/>
-              </a:lnSpc>
-            </a:pPr>
-            <a:r>
-              <a:rPr sz="2025" b="1">
-                <a:solidFill>
-                  <a:srgbClr val="FFFFFF"/>
-                </a:solidFill>
-                <a:latin typeface="Pretendard"/>
-                <a:ea typeface="Pretendard"/>
-                <a:cs typeface="Pretendard"/>
-              </a:rPr>
-              <a:t>작은 쪽</a:t>
-            </a:r>
-          </a:p>
-        </p:txBody>
-      </p:sp>
-      <p:sp>
-        <p:nvSpPr>
-          <p:cNvPr id="13" name="Rounded Rectangle 12"/>
-          <p:cNvSpPr/>
-          <p:nvPr/>
-        </p:nvSpPr>
-        <p:spPr>
-          <a:xfrm>
-            <a:off x="1390650" y="5583555"/>
-            <a:ext cx="3333274" cy="1214438"/>
+            <a:pPr algn="l">
+              <a:lnSpc>
+                <a:spcPct val="120000"/>
+              </a:lnSpc>
+            </a:pPr>
+            <a:r>
+              <a:rPr sz="1575" b="0">
+                <a:solidFill>
+                  <a:srgbClr val="3D3D3D"/>
+                </a:solidFill>
+                <a:latin typeface="Pretendard"/>
+                <a:ea typeface="Pretendard"/>
+                <a:cs typeface="Pretendard"/>
+              </a:rPr>
+              <a:t>작은 쪽을 모든 노드에 복사 — 조인 쪽 셔플 없음</a:t>
+            </a:r>
+          </a:p>
+        </p:txBody>
+      </p:sp>
+      <p:sp>
+        <p:nvSpPr>
+          <p:cNvPr id="13" name="Oval 12"/>
+          <p:cNvSpPr/>
+          <p:nvPr/>
+        </p:nvSpPr>
+        <p:spPr>
+          <a:xfrm>
+            <a:off x="1447800" y="5527358"/>
+            <a:ext cx="97155" cy="97155"/>
+          </a:xfrm>
+          <a:prstGeom prst="ellipse">
+            <a:avLst/>
+          </a:prstGeom>
+          <a:solidFill>
+            <a:srgbClr val="1E5BC6"/>
+          </a:solidFill>
+          <a:ln>
+            <a:noFill/>
+          </a:ln>
+          <a:effectLst/>
+        </p:spPr>
+        <p:txBody>
+          <a:bodyPr rtlCol="0" anchor="ctr" wrap="square"/>
+          <a:lstStyle/>
+          <a:p>
+            <a:pPr algn="ctr"/>
+          </a:p>
+        </p:txBody>
+      </p:sp>
+      <p:sp>
+        <p:nvSpPr>
+          <p:cNvPr id="14" name="TextBox 13"/>
+          <p:cNvSpPr txBox="1"/>
+          <p:nvPr/>
+        </p:nvSpPr>
+        <p:spPr>
+          <a:xfrm>
+            <a:off x="1633538" y="5349240"/>
+            <a:ext cx="6634162" cy="453390"/>
+          </a:xfrm>
+          <a:prstGeom prst="rect">
+            <a:avLst/>
+          </a:prstGeom>
+          <a:noFill/>
+        </p:spPr>
+        <p:txBody>
+          <a:bodyPr wrap="square" lIns="0" rIns="0" tIns="0" bIns="0" anchor="ctr">
+            <a:spAutoFit/>
+          </a:bodyPr>
+          <a:lstStyle/>
+          <a:p>
+            <a:pPr algn="l">
+              <a:lnSpc>
+                <a:spcPct val="120000"/>
+              </a:lnSpc>
+            </a:pPr>
+            <a:r>
+              <a:rPr sz="1575" b="0">
+                <a:solidFill>
+                  <a:srgbClr val="3D3D3D"/>
+                </a:solidFill>
+                <a:latin typeface="Pretendard"/>
+                <a:ea typeface="Pretendard"/>
+                <a:cs typeface="Pretendard"/>
+              </a:rPr>
+              <a:t>Iceberg 에서 읽은 표는 크기를 알아 힌트 없이</a:t>
+            </a:r>
+          </a:p>
+        </p:txBody>
+      </p:sp>
+      <p:sp>
+        <p:nvSpPr>
+          <p:cNvPr id="15" name="Oval 14"/>
+          <p:cNvSpPr/>
+          <p:nvPr/>
+        </p:nvSpPr>
+        <p:spPr>
+          <a:xfrm>
+            <a:off x="1447800" y="6037898"/>
+            <a:ext cx="97155" cy="97155"/>
+          </a:xfrm>
+          <a:prstGeom prst="ellipse">
+            <a:avLst/>
+          </a:prstGeom>
+          <a:solidFill>
+            <a:srgbClr val="1E5BC6"/>
+          </a:solidFill>
+          <a:ln>
+            <a:noFill/>
+          </a:ln>
+          <a:effectLst/>
+        </p:spPr>
+        <p:txBody>
+          <a:bodyPr rtlCol="0" anchor="ctr" wrap="square"/>
+          <a:lstStyle/>
+          <a:p>
+            <a:pPr algn="ctr"/>
+          </a:p>
+        </p:txBody>
+      </p:sp>
+      <p:sp>
+        <p:nvSpPr>
+          <p:cNvPr id="16" name="TextBox 15"/>
+          <p:cNvSpPr txBox="1"/>
+          <p:nvPr/>
+        </p:nvSpPr>
+        <p:spPr>
+          <a:xfrm>
+            <a:off x="1633538" y="5859780"/>
+            <a:ext cx="6634162" cy="453390"/>
+          </a:xfrm>
+          <a:prstGeom prst="rect">
+            <a:avLst/>
+          </a:prstGeom>
+          <a:noFill/>
+        </p:spPr>
+        <p:txBody>
+          <a:bodyPr wrap="square" lIns="0" rIns="0" tIns="0" bIns="0" anchor="ctr">
+            <a:spAutoFit/>
+          </a:bodyPr>
+          <a:lstStyle/>
+          <a:p>
+            <a:pPr algn="l">
+              <a:lnSpc>
+                <a:spcPct val="120000"/>
+              </a:lnSpc>
+            </a:pPr>
+            <a:r>
+              <a:rPr sz="1575" b="0">
+                <a:solidFill>
+                  <a:srgbClr val="3D3D3D"/>
+                </a:solidFill>
+                <a:latin typeface="Pretendard"/>
+                <a:ea typeface="Pretendard"/>
+                <a:cs typeface="Pretendard"/>
+              </a:rPr>
+              <a:t>F.broadcast(products) 로 「작다」고 알려 준다</a:t>
+            </a:r>
+          </a:p>
+        </p:txBody>
+      </p:sp>
+      <p:sp>
+        <p:nvSpPr>
+          <p:cNvPr id="17" name="TextBox 16"/>
+          <p:cNvSpPr txBox="1"/>
+          <p:nvPr/>
+        </p:nvSpPr>
+        <p:spPr>
+          <a:xfrm>
+            <a:off x="9772650" y="2857500"/>
+            <a:ext cx="7372350" cy="533400"/>
+          </a:xfrm>
+          <a:prstGeom prst="rect">
+            <a:avLst/>
+          </a:prstGeom>
+          <a:noFill/>
+        </p:spPr>
+        <p:txBody>
+          <a:bodyPr wrap="square" lIns="0" rIns="0" tIns="0" bIns="0" anchor="t">
+            <a:spAutoFit/>
+          </a:bodyPr>
+          <a:lstStyle/>
+          <a:p>
+            <a:pPr algn="l">
+              <a:lnSpc>
+                <a:spcPct val="110000"/>
+              </a:lnSpc>
+            </a:pPr>
+            <a:r>
+              <a:rPr sz="3150" b="1">
+                <a:solidFill>
+                  <a:srgbClr val="0D2B5E"/>
+                </a:solidFill>
+                <a:latin typeface="Pretendard"/>
+                <a:ea typeface="Pretendard"/>
+                <a:cs typeface="Pretendard"/>
+              </a:rPr>
+              <a:t>Sort Merge Join</a:t>
+            </a:r>
+          </a:p>
+        </p:txBody>
+      </p:sp>
+      <p:sp>
+        <p:nvSpPr>
+          <p:cNvPr id="18" name="TextBox 17"/>
+          <p:cNvSpPr txBox="1"/>
+          <p:nvPr/>
+        </p:nvSpPr>
+        <p:spPr>
+          <a:xfrm>
+            <a:off x="9772650" y="3467100"/>
+            <a:ext cx="7372350" cy="876300"/>
+          </a:xfrm>
+          <a:prstGeom prst="rect">
+            <a:avLst/>
+          </a:prstGeom>
+          <a:noFill/>
+        </p:spPr>
+        <p:txBody>
+          <a:bodyPr wrap="square" lIns="0" rIns="0" tIns="0" bIns="0" anchor="t">
+            <a:spAutoFit/>
+          </a:bodyPr>
+          <a:lstStyle/>
+          <a:p>
+            <a:pPr algn="l">
+              <a:lnSpc>
+                <a:spcPct val="146000"/>
+              </a:lnSpc>
+            </a:pPr>
+            <a:r>
+              <a:rPr sz="2250" b="0">
+                <a:solidFill>
+                  <a:srgbClr val="3D3D3D"/>
+                </a:solidFill>
+                <a:latin typeface="Pretendard"/>
+                <a:ea typeface="Pretendard"/>
+                <a:cs typeface="Pretendard"/>
+              </a:rPr>
+              <a:t>양쪽 다 크거나 — 크기를 모를 때</a:t>
+            </a:r>
+          </a:p>
+        </p:txBody>
+      </p:sp>
+      <p:sp>
+        <p:nvSpPr>
+          <p:cNvPr id="19" name="Rounded Rectangle 18"/>
+          <p:cNvSpPr/>
+          <p:nvPr/>
+        </p:nvSpPr>
+        <p:spPr>
+          <a:xfrm>
+            <a:off x="9772650" y="4610100"/>
+            <a:ext cx="7372350" cy="2857500"/>
           </a:xfrm>
           <a:prstGeom prst="roundRect">
             <a:avLst>
-              <a:gd name="adj" fmla="val 3921"/>
+              <a:gd name="adj" fmla="val 1666"/>
             </a:avLst>
           </a:prstGeom>
           <a:solidFill>
@@ -15386,57 +15756,16 @@
       </p:sp>
       <p:sp>
         <p:nvSpPr>
-          <p:cNvPr id="14" name="TextBox 13"/>
-          <p:cNvSpPr txBox="1"/>
-          <p:nvPr/>
-        </p:nvSpPr>
-        <p:spPr>
-          <a:xfrm>
-            <a:off x="1524000" y="5583555"/>
-            <a:ext cx="3066574" cy="1214438"/>
-          </a:xfrm>
-          <a:prstGeom prst="rect">
-            <a:avLst/>
-          </a:prstGeom>
-          <a:noFill/>
-        </p:spPr>
-        <p:txBody>
-          <a:bodyPr wrap="square" lIns="0" rIns="0" tIns="0" bIns="0" anchor="ctr">
-            <a:spAutoFit/>
-          </a:bodyPr>
-          <a:lstStyle/>
-          <a:p>
-            <a:pPr algn="ctr">
-              <a:lnSpc>
-                <a:spcPct val="135000"/>
-              </a:lnSpc>
-            </a:pPr>
-            <a:r>
-              <a:rPr sz="1500" b="0">
-                <a:solidFill>
-                  <a:srgbClr val="3D3D3D"/>
-                </a:solidFill>
-                <a:latin typeface="Pretendard"/>
-                <a:ea typeface="Pretendard"/>
-                <a:cs typeface="Pretendard"/>
-              </a:rPr>
-              <a:t>모든 노드에 복사</a:t>
-            </a:r>
-          </a:p>
-        </p:txBody>
-      </p:sp>
-      <p:sp>
-        <p:nvSpPr>
-          <p:cNvPr id="15" name="Right Arrow 14"/>
-          <p:cNvSpPr/>
-          <p:nvPr/>
-        </p:nvSpPr>
-        <p:spPr>
-          <a:xfrm>
-            <a:off x="4742974" y="5049202"/>
-            <a:ext cx="172402" cy="178118"/>
-          </a:xfrm>
-          <a:prstGeom prst="rightArrow">
+          <p:cNvPr id="20" name="Oval 19"/>
+          <p:cNvSpPr/>
+          <p:nvPr/>
+        </p:nvSpPr>
+        <p:spPr>
+          <a:xfrm>
+            <a:off x="10077450" y="5016817"/>
+            <a:ext cx="97155" cy="97155"/>
+          </a:xfrm>
+          <a:prstGeom prst="ellipse">
             <a:avLst/>
           </a:prstGeom>
           <a:solidFill>
@@ -15457,16 +15786,57 @@
       </p:sp>
       <p:sp>
         <p:nvSpPr>
-          <p:cNvPr id="16" name="Rectangle 15"/>
-          <p:cNvSpPr/>
-          <p:nvPr/>
-        </p:nvSpPr>
-        <p:spPr>
-          <a:xfrm>
-            <a:off x="4934426" y="4838700"/>
-            <a:ext cx="3333274" cy="599122"/>
-          </a:xfrm>
-          <a:prstGeom prst="rect">
+          <p:cNvPr id="21" name="TextBox 20"/>
+          <p:cNvSpPr txBox="1"/>
+          <p:nvPr/>
+        </p:nvSpPr>
+        <p:spPr>
+          <a:xfrm>
+            <a:off x="10263188" y="4838700"/>
+            <a:ext cx="6634162" cy="453390"/>
+          </a:xfrm>
+          <a:prstGeom prst="rect">
+            <a:avLst/>
+          </a:prstGeom>
+          <a:noFill/>
+        </p:spPr>
+        <p:txBody>
+          <a:bodyPr wrap="square" lIns="0" rIns="0" tIns="0" bIns="0" anchor="ctr">
+            <a:spAutoFit/>
+          </a:bodyPr>
+          <a:lstStyle/>
+          <a:p>
+            <a:pPr algn="l">
+              <a:lnSpc>
+                <a:spcPct val="120000"/>
+              </a:lnSpc>
+            </a:pPr>
+            <a:r>
+              <a:rPr sz="1575" b="0">
+                <a:solidFill>
+                  <a:srgbClr val="3D3D3D"/>
+                </a:solidFill>
+                <a:latin typeface="Pretendard"/>
+                <a:ea typeface="Pretendard"/>
+                <a:cs typeface="Pretendard"/>
+              </a:rPr>
+              <a:t>양쪽을 키로 재배치 — 조인 양쪽에 Exchange</a:t>
+            </a:r>
+          </a:p>
+        </p:txBody>
+      </p:sp>
+      <p:sp>
+        <p:nvSpPr>
+          <p:cNvPr id="22" name="Oval 21"/>
+          <p:cNvSpPr/>
+          <p:nvPr/>
+        </p:nvSpPr>
+        <p:spPr>
+          <a:xfrm>
+            <a:off x="10077450" y="5527358"/>
+            <a:ext cx="97155" cy="97155"/>
+          </a:xfrm>
+          <a:prstGeom prst="ellipse">
             <a:avLst/>
           </a:prstGeom>
           <a:solidFill>
@@ -15487,14 +15857,14 @@
       </p:sp>
       <p:sp>
         <p:nvSpPr>
-          <p:cNvPr id="17" name="TextBox 16"/>
-          <p:cNvSpPr txBox="1"/>
-          <p:nvPr/>
-        </p:nvSpPr>
-        <p:spPr>
-          <a:xfrm>
-            <a:off x="4934426" y="4838700"/>
-            <a:ext cx="3333274" cy="599122"/>
+          <p:cNvPr id="23" name="TextBox 22"/>
+          <p:cNvSpPr txBox="1"/>
+          <p:nvPr/>
+        </p:nvSpPr>
+        <p:spPr>
+          <a:xfrm>
+            <a:off x="10263188" y="5349240"/>
+            <a:ext cx="6634162" cy="453390"/>
           </a:xfrm>
           <a:prstGeom prst="rect">
             <a:avLst/>
@@ -15507,88 +15877,13 @@
           </a:bodyPr>
           <a:lstStyle/>
           <a:p>
-            <a:pPr algn="ctr">
-              <a:lnSpc>
-                <a:spcPct val="100000"/>
-              </a:lnSpc>
-            </a:pPr>
-            <a:r>
-              <a:rPr sz="2025" b="1">
-                <a:solidFill>
-                  <a:srgbClr val="FFFFFF"/>
-                </a:solidFill>
-                <a:latin typeface="Pretendard"/>
-                <a:ea typeface="Pretendard"/>
-                <a:cs typeface="Pretendard"/>
-              </a:rPr>
-              <a:t>셔플 없음</a:t>
-            </a:r>
-          </a:p>
-        </p:txBody>
-      </p:sp>
-      <p:sp>
-        <p:nvSpPr>
-          <p:cNvPr id="18" name="Rounded Rectangle 17"/>
-          <p:cNvSpPr/>
-          <p:nvPr/>
-        </p:nvSpPr>
-        <p:spPr>
-          <a:xfrm>
-            <a:off x="4934426" y="5583555"/>
-            <a:ext cx="3333274" cy="1214438"/>
-          </a:xfrm>
-          <a:prstGeom prst="roundRect">
-            <a:avLst>
-              <a:gd name="adj" fmla="val 3921"/>
-            </a:avLst>
-          </a:prstGeom>
-          <a:solidFill>
-            <a:srgbClr val="FAFBFD"/>
-          </a:solidFill>
-          <a:ln w="9525">
-            <a:solidFill>
-              <a:srgbClr val="DCE1E8"/>
-            </a:solidFill>
-          </a:ln>
-          <a:effectLst/>
-        </p:spPr>
-        <p:txBody>
-          <a:bodyPr rtlCol="0" anchor="ctr" wrap="square"/>
-          <a:lstStyle/>
-          <a:p>
-            <a:pPr algn="ctr"/>
-          </a:p>
-        </p:txBody>
-      </p:sp>
-      <p:sp>
-        <p:nvSpPr>
-          <p:cNvPr id="19" name="TextBox 18"/>
-          <p:cNvSpPr txBox="1"/>
-          <p:nvPr/>
-        </p:nvSpPr>
-        <p:spPr>
-          <a:xfrm>
-            <a:off x="5067776" y="5583555"/>
-            <a:ext cx="3066574" cy="1214438"/>
-          </a:xfrm>
-          <a:prstGeom prst="rect">
-            <a:avLst/>
-          </a:prstGeom>
-          <a:noFill/>
-        </p:spPr>
-        <p:txBody>
-          <a:bodyPr wrap="square" lIns="0" rIns="0" tIns="0" bIns="0" anchor="ctr">
-            <a:spAutoFit/>
-          </a:bodyPr>
-          <a:lstStyle/>
-          <a:p>
-            <a:pPr algn="ctr">
-              <a:lnSpc>
-                <a:spcPct val="135000"/>
-              </a:lnSpc>
-            </a:pPr>
-            <a:r>
-              <a:rPr sz="1500" b="0">
+            <a:pPr algn="l">
+              <a:lnSpc>
+                <a:spcPct val="120000"/>
+              </a:lnSpc>
+            </a:pPr>
+            <a:r>
+              <a:rPr sz="1575" b="0">
                 <a:solidFill>
                   <a:srgbClr val="3D3D3D"/>
                 </a:solidFill>
@@ -15596,143 +15891,27 @@
                 <a:ea typeface="Pretendard"/>
                 <a:cs typeface="Pretendard"/>
               </a:rPr>
-              <a:t>Exchange 가 없다</a:t>
-            </a:r>
-          </a:p>
-        </p:txBody>
-      </p:sp>
-      <p:sp>
-        <p:nvSpPr>
-          <p:cNvPr id="20" name="TextBox 19"/>
-          <p:cNvSpPr txBox="1"/>
-          <p:nvPr/>
-        </p:nvSpPr>
-        <p:spPr>
-          <a:xfrm>
-            <a:off x="9772650" y="2857500"/>
-            <a:ext cx="7372350" cy="533400"/>
-          </a:xfrm>
-          <a:prstGeom prst="rect">
-            <a:avLst/>
-          </a:prstGeom>
-          <a:noFill/>
-        </p:spPr>
-        <p:txBody>
-          <a:bodyPr wrap="square" lIns="0" rIns="0" tIns="0" bIns="0" anchor="t">
-            <a:spAutoFit/>
-          </a:bodyPr>
-          <a:lstStyle/>
-          <a:p>
-            <a:pPr algn="l">
-              <a:lnSpc>
-                <a:spcPct val="110000"/>
-              </a:lnSpc>
-            </a:pPr>
-            <a:r>
-              <a:rPr sz="3150" b="1">
-                <a:solidFill>
-                  <a:srgbClr val="0D2B5E"/>
-                </a:solidFill>
-                <a:latin typeface="Pretendard"/>
-                <a:ea typeface="Pretendard"/>
-                <a:cs typeface="Pretendard"/>
-              </a:rPr>
-              <a:t>Sort Merge Join</a:t>
-            </a:r>
-          </a:p>
-        </p:txBody>
-      </p:sp>
-      <p:sp>
-        <p:nvSpPr>
-          <p:cNvPr id="21" name="TextBox 20"/>
-          <p:cNvSpPr txBox="1"/>
-          <p:nvPr/>
-        </p:nvSpPr>
-        <p:spPr>
-          <a:xfrm>
-            <a:off x="9772650" y="3467100"/>
-            <a:ext cx="7372350" cy="876300"/>
-          </a:xfrm>
-          <a:prstGeom prst="rect">
-            <a:avLst/>
-          </a:prstGeom>
-          <a:noFill/>
-        </p:spPr>
-        <p:txBody>
-          <a:bodyPr wrap="square" lIns="0" rIns="0" tIns="0" bIns="0" anchor="t">
-            <a:spAutoFit/>
-          </a:bodyPr>
-          <a:lstStyle/>
-          <a:p>
-            <a:pPr algn="l">
-              <a:lnSpc>
-                <a:spcPct val="146000"/>
-              </a:lnSpc>
-            </a:pPr>
-            <a:r>
-              <a:rPr sz="2250" b="0">
-                <a:solidFill>
-                  <a:srgbClr val="3D3D3D"/>
-                </a:solidFill>
-                <a:latin typeface="Pretendard"/>
-                <a:ea typeface="Pretendard"/>
-                <a:cs typeface="Pretendard"/>
-              </a:rPr>
-              <a:t>양쪽 다 클 때 — 성능 튜닝의 기본(5-5)</a:t>
-            </a:r>
-          </a:p>
-        </p:txBody>
-      </p:sp>
-      <p:sp>
-        <p:nvSpPr>
-          <p:cNvPr id="22" name="Rounded Rectangle 21"/>
-          <p:cNvSpPr/>
-          <p:nvPr/>
-        </p:nvSpPr>
-        <p:spPr>
-          <a:xfrm>
-            <a:off x="9772650" y="4610100"/>
-            <a:ext cx="7372350" cy="2857500"/>
-          </a:xfrm>
-          <a:prstGeom prst="roundRect">
-            <a:avLst>
-              <a:gd name="adj" fmla="val 1666"/>
-            </a:avLst>
-          </a:prstGeom>
-          <a:solidFill>
-            <a:srgbClr val="FAFBFD"/>
-          </a:solidFill>
-          <a:ln w="9525">
-            <a:solidFill>
-              <a:srgbClr val="DCE1E8"/>
-            </a:solidFill>
-          </a:ln>
-          <a:effectLst/>
-        </p:spPr>
-        <p:txBody>
-          <a:bodyPr rtlCol="0" anchor="ctr" wrap="square"/>
-          <a:lstStyle/>
-          <a:p>
-            <a:pPr algn="ctr"/>
-          </a:p>
-        </p:txBody>
-      </p:sp>
-      <p:sp>
-        <p:nvSpPr>
-          <p:cNvPr id="23" name="Rectangle 22"/>
-          <p:cNvSpPr/>
-          <p:nvPr/>
-        </p:nvSpPr>
-        <p:spPr>
-          <a:xfrm>
-            <a:off x="10020300" y="4838700"/>
-            <a:ext cx="3333274" cy="599122"/>
-          </a:xfrm>
-          <a:prstGeom prst="rect">
-            <a:avLst/>
-          </a:prstGeom>
-          <a:solidFill>
-            <a:srgbClr val="0D2B5E"/>
+              <a:t>createDataFrame 표는 크기를 몰라 아주 크다고 본다</a:t>
+            </a:r>
+          </a:p>
+        </p:txBody>
+      </p:sp>
+      <p:sp>
+        <p:nvSpPr>
+          <p:cNvPr id="24" name="Oval 23"/>
+          <p:cNvSpPr/>
+          <p:nvPr/>
+        </p:nvSpPr>
+        <p:spPr>
+          <a:xfrm>
+            <a:off x="10077450" y="6037898"/>
+            <a:ext cx="97155" cy="97155"/>
+          </a:xfrm>
+          <a:prstGeom prst="ellipse">
+            <a:avLst/>
+          </a:prstGeom>
+          <a:solidFill>
+            <a:srgbClr val="1E5BC6"/>
           </a:solidFill>
           <a:ln>
             <a:noFill/>
@@ -15749,14 +15928,14 @@
       </p:sp>
       <p:sp>
         <p:nvSpPr>
-          <p:cNvPr id="24" name="TextBox 23"/>
-          <p:cNvSpPr txBox="1"/>
-          <p:nvPr/>
-        </p:nvSpPr>
-        <p:spPr>
-          <a:xfrm>
-            <a:off x="10020300" y="4838700"/>
-            <a:ext cx="3333274" cy="599122"/>
+          <p:cNvPr id="25" name="TextBox 24"/>
+          <p:cNvSpPr txBox="1"/>
+          <p:nvPr/>
+        </p:nvSpPr>
+        <p:spPr>
+          <a:xfrm>
+            <a:off x="10263188" y="5859780"/>
+            <a:ext cx="6634162" cy="453390"/>
           </a:xfrm>
           <a:prstGeom prst="rect">
             <a:avLst/>
@@ -15769,88 +15948,13 @@
           </a:bodyPr>
           <a:lstStyle/>
           <a:p>
-            <a:pPr algn="ctr">
-              <a:lnSpc>
-                <a:spcPct val="100000"/>
-              </a:lnSpc>
-            </a:pPr>
-            <a:r>
-              <a:rPr sz="2025" b="1">
-                <a:solidFill>
-                  <a:srgbClr val="FFFFFF"/>
-                </a:solidFill>
-                <a:latin typeface="Pretendard"/>
-                <a:ea typeface="Pretendard"/>
-                <a:cs typeface="Pretendard"/>
-              </a:rPr>
-              <a:t>양쪽을 키로</a:t>
-            </a:r>
-          </a:p>
-        </p:txBody>
-      </p:sp>
-      <p:sp>
-        <p:nvSpPr>
-          <p:cNvPr id="25" name="Rounded Rectangle 24"/>
-          <p:cNvSpPr/>
-          <p:nvPr/>
-        </p:nvSpPr>
-        <p:spPr>
-          <a:xfrm>
-            <a:off x="10020300" y="5583555"/>
-            <a:ext cx="3333274" cy="1214438"/>
-          </a:xfrm>
-          <a:prstGeom prst="roundRect">
-            <a:avLst>
-              <a:gd name="adj" fmla="val 3921"/>
-            </a:avLst>
-          </a:prstGeom>
-          <a:solidFill>
-            <a:srgbClr val="FAFBFD"/>
-          </a:solidFill>
-          <a:ln w="9525">
-            <a:solidFill>
-              <a:srgbClr val="DCE1E8"/>
-            </a:solidFill>
-          </a:ln>
-          <a:effectLst/>
-        </p:spPr>
-        <p:txBody>
-          <a:bodyPr rtlCol="0" anchor="ctr" wrap="square"/>
-          <a:lstStyle/>
-          <a:p>
-            <a:pPr algn="ctr"/>
-          </a:p>
-        </p:txBody>
-      </p:sp>
-      <p:sp>
-        <p:nvSpPr>
-          <p:cNvPr id="26" name="TextBox 25"/>
-          <p:cNvSpPr txBox="1"/>
-          <p:nvPr/>
-        </p:nvSpPr>
-        <p:spPr>
-          <a:xfrm>
-            <a:off x="10153650" y="5583555"/>
-            <a:ext cx="3066574" cy="1214438"/>
-          </a:xfrm>
-          <a:prstGeom prst="rect">
-            <a:avLst/>
-          </a:prstGeom>
-          <a:noFill/>
-        </p:spPr>
-        <p:txBody>
-          <a:bodyPr wrap="square" lIns="0" rIns="0" tIns="0" bIns="0" anchor="ctr">
-            <a:spAutoFit/>
-          </a:bodyPr>
-          <a:lstStyle/>
-          <a:p>
-            <a:pPr algn="ctr">
-              <a:lnSpc>
-                <a:spcPct val="135000"/>
-              </a:lnSpc>
-            </a:pPr>
-            <a:r>
-              <a:rPr sz="1500" b="0">
+            <a:pPr algn="l">
+              <a:lnSpc>
+                <a:spcPct val="120000"/>
+              </a:lnSpc>
+            </a:pPr>
+            <a:r>
+              <a:rPr sz="1575" b="0">
                 <a:solidFill>
                   <a:srgbClr val="3D3D3D"/>
                 </a:solidFill>
@@ -15858,27 +15962,27 @@
                 <a:ea typeface="Pretendard"/>
                 <a:cs typeface="Pretendard"/>
               </a:rPr>
-              <a:t>재배치</a:t>
-            </a:r>
-          </a:p>
-        </p:txBody>
-      </p:sp>
-      <p:sp>
-        <p:nvSpPr>
-          <p:cNvPr id="27" name="Right Arrow 26"/>
-          <p:cNvSpPr/>
-          <p:nvPr/>
-        </p:nvSpPr>
-        <p:spPr>
-          <a:xfrm>
-            <a:off x="13372624" y="5049202"/>
-            <a:ext cx="172402" cy="178118"/>
-          </a:xfrm>
-          <a:prstGeom prst="rightArrow">
-            <a:avLst/>
-          </a:prstGeom>
-          <a:solidFill>
-            <a:srgbClr val="1E5BC6"/>
+              <a:t>세 줄짜리 products 도 여기로 간다(실측)</a:t>
+            </a:r>
+          </a:p>
+        </p:txBody>
+      </p:sp>
+      <p:sp>
+        <p:nvSpPr>
+          <p:cNvPr id="26" name="Oval 25"/>
+          <p:cNvSpPr/>
+          <p:nvPr/>
+        </p:nvSpPr>
+        <p:spPr>
+          <a:xfrm>
+            <a:off x="8686800" y="3771900"/>
+            <a:ext cx="914400" cy="914400"/>
+          </a:xfrm>
+          <a:prstGeom prst="ellipse">
+            <a:avLst/>
+          </a:prstGeom>
+          <a:solidFill>
+            <a:srgbClr val="0D2B5E"/>
           </a:solidFill>
           <a:ln>
             <a:noFill/>
@@ -15895,20 +15999,61 @@
       </p:sp>
       <p:sp>
         <p:nvSpPr>
+          <p:cNvPr id="27" name="TextBox 26"/>
+          <p:cNvSpPr txBox="1"/>
+          <p:nvPr/>
+        </p:nvSpPr>
+        <p:spPr>
+          <a:xfrm>
+            <a:off x="8686800" y="4057650"/>
+            <a:ext cx="914400" cy="381000"/>
+          </a:xfrm>
+          <a:prstGeom prst="rect">
+            <a:avLst/>
+          </a:prstGeom>
+          <a:noFill/>
+        </p:spPr>
+        <p:txBody>
+          <a:bodyPr wrap="square" lIns="0" rIns="0" tIns="0" bIns="0" anchor="t">
+            <a:spAutoFit/>
+          </a:bodyPr>
+          <a:lstStyle/>
+          <a:p>
+            <a:pPr algn="ctr">
+              <a:lnSpc>
+                <a:spcPct val="100000"/>
+              </a:lnSpc>
+            </a:pPr>
+            <a:r>
+              <a:rPr sz="2250" b="1">
+                <a:solidFill>
+                  <a:srgbClr val="FFFFFF"/>
+                </a:solidFill>
+                <a:latin typeface="Pretendard"/>
+                <a:ea typeface="Pretendard"/>
+                <a:cs typeface="Pretendard"/>
+              </a:rPr>
+              <a:t>VS</a:t>
+            </a:r>
+          </a:p>
+        </p:txBody>
+      </p:sp>
+      <p:sp>
+        <p:nvSpPr>
           <p:cNvPr id="28" name="Rectangle 27"/>
           <p:cNvSpPr/>
           <p:nvPr/>
         </p:nvSpPr>
         <p:spPr>
           <a:xfrm>
-            <a:off x="13564076" y="4838700"/>
-            <a:ext cx="3333274" cy="599122"/>
-          </a:xfrm>
-          <a:prstGeom prst="rect">
-            <a:avLst/>
-          </a:prstGeom>
-          <a:solidFill>
-            <a:srgbClr val="1E5BC6"/>
+            <a:off x="1143000" y="8058150"/>
+            <a:ext cx="16002000" cy="9525"/>
+          </a:xfrm>
+          <a:prstGeom prst="rect">
+            <a:avLst/>
+          </a:prstGeom>
+          <a:solidFill>
+            <a:srgbClr val="DCE1E8"/>
           </a:solidFill>
           <a:ln>
             <a:noFill/>
@@ -15931,223 +16076,6 @@
         </p:nvSpPr>
         <p:spPr>
           <a:xfrm>
-            <a:off x="13564076" y="4838700"/>
-            <a:ext cx="3333274" cy="599122"/>
-          </a:xfrm>
-          <a:prstGeom prst="rect">
-            <a:avLst/>
-          </a:prstGeom>
-          <a:noFill/>
-        </p:spPr>
-        <p:txBody>
-          <a:bodyPr wrap="square" lIns="0" rIns="0" tIns="0" bIns="0" anchor="ctr">
-            <a:spAutoFit/>
-          </a:bodyPr>
-          <a:lstStyle/>
-          <a:p>
-            <a:pPr algn="ctr">
-              <a:lnSpc>
-                <a:spcPct val="100000"/>
-              </a:lnSpc>
-            </a:pPr>
-            <a:r>
-              <a:rPr sz="2025" b="1">
-                <a:solidFill>
-                  <a:srgbClr val="FFFFFF"/>
-                </a:solidFill>
-                <a:latin typeface="Pretendard"/>
-                <a:ea typeface="Pretendard"/>
-                <a:cs typeface="Pretendard"/>
-              </a:rPr>
-              <a:t>셔플 발생</a:t>
-            </a:r>
-          </a:p>
-        </p:txBody>
-      </p:sp>
-      <p:sp>
-        <p:nvSpPr>
-          <p:cNvPr id="30" name="Rounded Rectangle 29"/>
-          <p:cNvSpPr/>
-          <p:nvPr/>
-        </p:nvSpPr>
-        <p:spPr>
-          <a:xfrm>
-            <a:off x="13564076" y="5583555"/>
-            <a:ext cx="3333274" cy="1214438"/>
-          </a:xfrm>
-          <a:prstGeom prst="roundRect">
-            <a:avLst>
-              <a:gd name="adj" fmla="val 3921"/>
-            </a:avLst>
-          </a:prstGeom>
-          <a:solidFill>
-            <a:srgbClr val="FAFBFD"/>
-          </a:solidFill>
-          <a:ln w="9525">
-            <a:solidFill>
-              <a:srgbClr val="DCE1E8"/>
-            </a:solidFill>
-          </a:ln>
-          <a:effectLst/>
-        </p:spPr>
-        <p:txBody>
-          <a:bodyPr rtlCol="0" anchor="ctr" wrap="square"/>
-          <a:lstStyle/>
-          <a:p>
-            <a:pPr algn="ctr"/>
-          </a:p>
-        </p:txBody>
-      </p:sp>
-      <p:sp>
-        <p:nvSpPr>
-          <p:cNvPr id="31" name="TextBox 30"/>
-          <p:cNvSpPr txBox="1"/>
-          <p:nvPr/>
-        </p:nvSpPr>
-        <p:spPr>
-          <a:xfrm>
-            <a:off x="13697426" y="5583555"/>
-            <a:ext cx="3066574" cy="1214438"/>
-          </a:xfrm>
-          <a:prstGeom prst="rect">
-            <a:avLst/>
-          </a:prstGeom>
-          <a:noFill/>
-        </p:spPr>
-        <p:txBody>
-          <a:bodyPr wrap="square" lIns="0" rIns="0" tIns="0" bIns="0" anchor="ctr">
-            <a:spAutoFit/>
-          </a:bodyPr>
-          <a:lstStyle/>
-          <a:p>
-            <a:pPr algn="ctr">
-              <a:lnSpc>
-                <a:spcPct val="135000"/>
-              </a:lnSpc>
-            </a:pPr>
-            <a:r>
-              <a:rPr sz="1500" b="0">
-                <a:solidFill>
-                  <a:srgbClr val="3D3D3D"/>
-                </a:solidFill>
-                <a:latin typeface="Pretendard"/>
-                <a:ea typeface="Pretendard"/>
-                <a:cs typeface="Pretendard"/>
-              </a:rPr>
-              <a:t>Exchange 가 함께</a:t>
-            </a:r>
-          </a:p>
-        </p:txBody>
-      </p:sp>
-      <p:sp>
-        <p:nvSpPr>
-          <p:cNvPr id="32" name="Oval 31"/>
-          <p:cNvSpPr/>
-          <p:nvPr/>
-        </p:nvSpPr>
-        <p:spPr>
-          <a:xfrm>
-            <a:off x="8686800" y="3771900"/>
-            <a:ext cx="914400" cy="914400"/>
-          </a:xfrm>
-          <a:prstGeom prst="ellipse">
-            <a:avLst/>
-          </a:prstGeom>
-          <a:solidFill>
-            <a:srgbClr val="0D2B5E"/>
-          </a:solidFill>
-          <a:ln>
-            <a:noFill/>
-          </a:ln>
-          <a:effectLst/>
-        </p:spPr>
-        <p:txBody>
-          <a:bodyPr rtlCol="0" anchor="ctr" wrap="square"/>
-          <a:lstStyle/>
-          <a:p>
-            <a:pPr algn="ctr"/>
-          </a:p>
-        </p:txBody>
-      </p:sp>
-      <p:sp>
-        <p:nvSpPr>
-          <p:cNvPr id="33" name="TextBox 32"/>
-          <p:cNvSpPr txBox="1"/>
-          <p:nvPr/>
-        </p:nvSpPr>
-        <p:spPr>
-          <a:xfrm>
-            <a:off x="8686800" y="4057650"/>
-            <a:ext cx="914400" cy="381000"/>
-          </a:xfrm>
-          <a:prstGeom prst="rect">
-            <a:avLst/>
-          </a:prstGeom>
-          <a:noFill/>
-        </p:spPr>
-        <p:txBody>
-          <a:bodyPr wrap="square" lIns="0" rIns="0" tIns="0" bIns="0" anchor="t">
-            <a:spAutoFit/>
-          </a:bodyPr>
-          <a:lstStyle/>
-          <a:p>
-            <a:pPr algn="ctr">
-              <a:lnSpc>
-                <a:spcPct val="100000"/>
-              </a:lnSpc>
-            </a:pPr>
-            <a:r>
-              <a:rPr sz="2250" b="1">
-                <a:solidFill>
-                  <a:srgbClr val="FFFFFF"/>
-                </a:solidFill>
-                <a:latin typeface="Pretendard"/>
-                <a:ea typeface="Pretendard"/>
-                <a:cs typeface="Pretendard"/>
-              </a:rPr>
-              <a:t>VS</a:t>
-            </a:r>
-          </a:p>
-        </p:txBody>
-      </p:sp>
-      <p:sp>
-        <p:nvSpPr>
-          <p:cNvPr id="34" name="Rectangle 33"/>
-          <p:cNvSpPr/>
-          <p:nvPr/>
-        </p:nvSpPr>
-        <p:spPr>
-          <a:xfrm>
-            <a:off x="1143000" y="8058150"/>
-            <a:ext cx="16002000" cy="9525"/>
-          </a:xfrm>
-          <a:prstGeom prst="rect">
-            <a:avLst/>
-          </a:prstGeom>
-          <a:solidFill>
-            <a:srgbClr val="DCE1E8"/>
-          </a:solidFill>
-          <a:ln>
-            <a:noFill/>
-          </a:ln>
-          <a:effectLst/>
-        </p:spPr>
-        <p:txBody>
-          <a:bodyPr rtlCol="0" anchor="ctr" wrap="square"/>
-          <a:lstStyle/>
-          <a:p>
-            <a:pPr algn="ctr"/>
-          </a:p>
-        </p:txBody>
-      </p:sp>
-      <p:sp>
-        <p:nvSpPr>
-          <p:cNvPr id="35" name="TextBox 34"/>
-          <p:cNvSpPr txBox="1"/>
-          <p:nvPr/>
-        </p:nvSpPr>
-        <p:spPr>
-          <a:xfrm>
             <a:off x="1143000" y="8248650"/>
             <a:ext cx="13335000" cy="323850"/>
           </a:xfrm>
@@ -16183,7 +16111,7 @@
       </p:sp>
       <p:sp>
         <p:nvSpPr>
-          <p:cNvPr id="36" name="TextBox 35"/>
+          <p:cNvPr id="30" name="TextBox 29"/>
           <p:cNvSpPr txBox="1"/>
           <p:nvPr/>
         </p:nvSpPr>

</xml_diff>